<commit_message>
Add live app screenshot to the Logic slide
- Capture real Streamlit output (plan table + confidence) via Playwright
- Redesign slide 3 as two columns: 4-step loop on the left, live app on the right

Co-Authored-By: Claude Opus 4.8 <noreply@anthropic.com>
</commit_message>
<xml_diff>
--- a/PawPal_Plus_Presentation.pptx
+++ b/PawPal_Plus_Presentation.pptx
@@ -3810,8 +3810,8 @@
         </p:nvSpPr>
         <p:spPr>
           <a:xfrm>
-            <a:off x="914400" y="1874519"/>
-            <a:ext cx="10332720" cy="457200"/>
+            <a:off x="914400" y="1783080"/>
+            <a:ext cx="5669280" cy="457200"/>
           </a:xfrm>
           <a:prstGeom prst="rect">
             <a:avLst/>
@@ -3833,7 +3833,7 @@
               </a:spcAft>
             </a:pPr>
             <a:r>
-              <a:rPr sz="1700" b="0">
+              <a:rPr sz="1500" b="0">
                 <a:solidFill>
                   <a:srgbClr val="5C6B73"/>
                 </a:solidFill>
@@ -3846,20 +3846,20 @@
       </p:sp>
       <p:sp>
         <p:nvSpPr>
-          <p:cNvPr id="6" name="Rounded Rectangle 5"/>
+          <p:cNvPr id="6" name="Oval 5"/>
           <p:cNvSpPr/>
           <p:nvPr/>
         </p:nvSpPr>
         <p:spPr>
           <a:xfrm>
-            <a:off x="640080" y="2514600"/>
-            <a:ext cx="2514600" cy="2743200"/>
-          </a:xfrm>
-          <a:prstGeom prst="roundRect">
+            <a:off x="868680" y="2331720"/>
+            <a:ext cx="457200" cy="457200"/>
+          </a:xfrm>
+          <a:prstGeom prst="ellipse">
             <a:avLst/>
           </a:prstGeom>
           <a:solidFill>
-            <a:srgbClr val="FFFFFF"/>
+            <a:srgbClr val="148F93"/>
           </a:solidFill>
           <a:ln>
             <a:noFill/>
@@ -3885,21 +3885,113 @@
           <a:lstStyle/>
           <a:p>
             <a:pPr algn="ctr"/>
-          </a:p>
-        </p:txBody>
-      </p:sp>
-      <p:sp>
-        <p:nvSpPr>
-          <p:cNvPr id="7" name="Rounded Rectangle 6"/>
+            <a:r>
+              <a:rPr sz="1700" b="1">
+                <a:solidFill>
+                  <a:srgbClr val="FFFFFF"/>
+                </a:solidFill>
+              </a:rPr>
+              <a:t>1</a:t>
+            </a:r>
+          </a:p>
+        </p:txBody>
+      </p:sp>
+      <p:sp>
+        <p:nvSpPr>
+          <p:cNvPr id="7" name="TextBox 6"/>
+          <p:cNvSpPr txBox="1"/>
+          <p:nvPr/>
+        </p:nvSpPr>
+        <p:spPr>
+          <a:xfrm>
+            <a:off x="1508760" y="2276856"/>
+            <a:ext cx="4937760" cy="365760"/>
+          </a:xfrm>
+          <a:prstGeom prst="rect">
+            <a:avLst/>
+          </a:prstGeom>
+          <a:noFill/>
+        </p:spPr>
+        <p:txBody>
+          <a:bodyPr wrap="square" anchor="t">
+            <a:spAutoFit/>
+          </a:bodyPr>
+          <a:lstStyle/>
+          <a:p>
+            <a:pPr algn="l">
+              <a:lnSpc>
+                <a:spcPct val="105000"/>
+              </a:lnSpc>
+              <a:spcAft>
+                <a:spcPts val="0"/>
+              </a:spcAft>
+            </a:pPr>
+            <a:r>
+              <a:rPr sz="1600" b="1">
+                <a:solidFill>
+                  <a:srgbClr val="1A2332"/>
+                </a:solidFill>
+                <a:latin typeface="Calibri"/>
+              </a:rPr>
+              <a:t>Look it up</a:t>
+            </a:r>
+          </a:p>
+        </p:txBody>
+      </p:sp>
+      <p:sp>
+        <p:nvSpPr>
+          <p:cNvPr id="8" name="TextBox 7"/>
+          <p:cNvSpPr txBox="1"/>
+          <p:nvPr/>
+        </p:nvSpPr>
+        <p:spPr>
+          <a:xfrm>
+            <a:off x="1508760" y="2624328"/>
+            <a:ext cx="4937760" cy="548640"/>
+          </a:xfrm>
+          <a:prstGeom prst="rect">
+            <a:avLst/>
+          </a:prstGeom>
+          <a:noFill/>
+        </p:spPr>
+        <p:txBody>
+          <a:bodyPr wrap="square" anchor="t">
+            <a:spAutoFit/>
+          </a:bodyPr>
+          <a:lstStyle/>
+          <a:p>
+            <a:pPr algn="l">
+              <a:lnSpc>
+                <a:spcPct val="105000"/>
+              </a:lnSpc>
+              <a:spcAft>
+                <a:spcPts val="0"/>
+              </a:spcAft>
+            </a:pPr>
+            <a:r>
+              <a:rPr sz="1250" b="0">
+                <a:solidFill>
+                  <a:srgbClr val="5C6B73"/>
+                </a:solidFill>
+                <a:latin typeface="Calibri"/>
+              </a:rPr>
+              <a:t>Pulls care guidance for each task from a small knowledge base.</a:t>
+            </a:r>
+          </a:p>
+        </p:txBody>
+      </p:sp>
+      <p:sp>
+        <p:nvSpPr>
+          <p:cNvPr id="9" name="Oval 8"/>
           <p:cNvSpPr/>
           <p:nvPr/>
         </p:nvSpPr>
         <p:spPr>
           <a:xfrm>
-            <a:off x="640080" y="2514600"/>
-            <a:ext cx="2514600" cy="457200"/>
-          </a:xfrm>
-          <a:prstGeom prst="roundRect">
+            <a:off x="868680" y="3246120"/>
+            <a:ext cx="457200" cy="457200"/>
+          </a:xfrm>
+          <a:prstGeom prst="ellipse">
             <a:avLst/>
           </a:prstGeom>
           <a:solidFill>
@@ -3929,61 +4021,27 @@
           <a:lstStyle/>
           <a:p>
             <a:pPr algn="ctr"/>
-          </a:p>
-        </p:txBody>
-      </p:sp>
-      <p:sp>
-        <p:nvSpPr>
-          <p:cNvPr id="8" name="TextBox 7"/>
+            <a:r>
+              <a:rPr sz="1700" b="1">
+                <a:solidFill>
+                  <a:srgbClr val="FFFFFF"/>
+                </a:solidFill>
+              </a:rPr>
+              <a:t>2</a:t>
+            </a:r>
+          </a:p>
+        </p:txBody>
+      </p:sp>
+      <p:sp>
+        <p:nvSpPr>
+          <p:cNvPr id="10" name="TextBox 9"/>
           <p:cNvSpPr txBox="1"/>
           <p:nvPr/>
         </p:nvSpPr>
         <p:spPr>
           <a:xfrm>
-            <a:off x="640080" y="2542032"/>
-            <a:ext cx="2514600" cy="402336"/>
-          </a:xfrm>
-          <a:prstGeom prst="rect">
-            <a:avLst/>
-          </a:prstGeom>
-          <a:noFill/>
-        </p:spPr>
-        <p:txBody>
-          <a:bodyPr wrap="square" anchor="t">
-            <a:spAutoFit/>
-          </a:bodyPr>
-          <a:lstStyle/>
-          <a:p>
-            <a:pPr algn="ctr">
-              <a:lnSpc>
-                <a:spcPct val="105000"/>
-              </a:lnSpc>
-              <a:spcAft>
-                <a:spcPts val="0"/>
-              </a:spcAft>
-            </a:pPr>
-            <a:r>
-              <a:rPr sz="1200" b="1">
-                <a:solidFill>
-                  <a:srgbClr val="FFFFFF"/>
-                </a:solidFill>
-                <a:latin typeface="Calibri"/>
-              </a:rPr>
-              <a:t>STEP 1</a:t>
-            </a:r>
-          </a:p>
-        </p:txBody>
-      </p:sp>
-      <p:sp>
-        <p:nvSpPr>
-          <p:cNvPr id="9" name="TextBox 8"/>
-          <p:cNvSpPr txBox="1"/>
-          <p:nvPr/>
-        </p:nvSpPr>
-        <p:spPr>
-          <a:xfrm>
-            <a:off x="841248" y="3108960"/>
-            <a:ext cx="2148840" cy="640080"/>
+            <a:off x="1508760" y="3191256"/>
+            <a:ext cx="4937760" cy="365760"/>
           </a:xfrm>
           <a:prstGeom prst="rect">
             <a:avLst/>
@@ -4005,27 +4063,27 @@
               </a:spcAft>
             </a:pPr>
             <a:r>
-              <a:rPr sz="1500" b="1">
+              <a:rPr sz="1600" b="1">
                 <a:solidFill>
                   <a:srgbClr val="1A2332"/>
                 </a:solidFill>
                 <a:latin typeface="Calibri"/>
               </a:rPr>
-              <a:t>Look it up</a:t>
-            </a:r>
-          </a:p>
-        </p:txBody>
-      </p:sp>
-      <p:sp>
-        <p:nvSpPr>
-          <p:cNvPr id="10" name="TextBox 9"/>
+              <a:t>Prioritize</a:t>
+            </a:r>
+          </a:p>
+        </p:txBody>
+      </p:sp>
+      <p:sp>
+        <p:nvSpPr>
+          <p:cNvPr id="11" name="TextBox 10"/>
           <p:cNvSpPr txBox="1"/>
           <p:nvPr/>
         </p:nvSpPr>
         <p:spPr>
           <a:xfrm>
-            <a:off x="841248" y="3703320"/>
-            <a:ext cx="2148840" cy="1463040"/>
+            <a:off x="1508760" y="3538728"/>
+            <a:ext cx="4937760" cy="548640"/>
           </a:xfrm>
           <a:prstGeom prst="rect">
             <a:avLst/>
@@ -4040,7 +4098,7 @@
           <a:p>
             <a:pPr algn="l">
               <a:lnSpc>
-                <a:spcPct val="110000"/>
+                <a:spcPct val="105000"/>
               </a:lnSpc>
               <a:spcAft>
                 <a:spcPts val="0"/>
@@ -4053,27 +4111,27 @@
                 </a:solidFill>
                 <a:latin typeface="Calibri"/>
               </a:rPr>
-              <a:t>Pulls care guidance for each task from a small knowledge base.</a:t>
-            </a:r>
-          </a:p>
-        </p:txBody>
-      </p:sp>
-      <p:sp>
-        <p:nvSpPr>
-          <p:cNvPr id="11" name="Rounded Rectangle 10"/>
+              <a:t>Boosts safety-first tasks: meds › feeding › walks › grooming.</a:t>
+            </a:r>
+          </a:p>
+        </p:txBody>
+      </p:sp>
+      <p:sp>
+        <p:nvSpPr>
+          <p:cNvPr id="12" name="Oval 11"/>
           <p:cNvSpPr/>
           <p:nvPr/>
         </p:nvSpPr>
         <p:spPr>
           <a:xfrm>
-            <a:off x="3310128" y="2514600"/>
-            <a:ext cx="2514600" cy="2743200"/>
-          </a:xfrm>
-          <a:prstGeom prst="roundRect">
+            <a:off x="868680" y="4160520"/>
+            <a:ext cx="457200" cy="457200"/>
+          </a:xfrm>
+          <a:prstGeom prst="ellipse">
             <a:avLst/>
           </a:prstGeom>
           <a:solidFill>
-            <a:srgbClr val="FFFFFF"/>
+            <a:srgbClr val="148F93"/>
           </a:solidFill>
           <a:ln>
             <a:noFill/>
@@ -4099,21 +4157,113 @@
           <a:lstStyle/>
           <a:p>
             <a:pPr algn="ctr"/>
-          </a:p>
-        </p:txBody>
-      </p:sp>
-      <p:sp>
-        <p:nvSpPr>
-          <p:cNvPr id="12" name="Rounded Rectangle 11"/>
+            <a:r>
+              <a:rPr sz="1700" b="1">
+                <a:solidFill>
+                  <a:srgbClr val="FFFFFF"/>
+                </a:solidFill>
+              </a:rPr>
+              <a:t>3</a:t>
+            </a:r>
+          </a:p>
+        </p:txBody>
+      </p:sp>
+      <p:sp>
+        <p:nvSpPr>
+          <p:cNvPr id="13" name="TextBox 12"/>
+          <p:cNvSpPr txBox="1"/>
+          <p:nvPr/>
+        </p:nvSpPr>
+        <p:spPr>
+          <a:xfrm>
+            <a:off x="1508760" y="4105656"/>
+            <a:ext cx="4937760" cy="365760"/>
+          </a:xfrm>
+          <a:prstGeom prst="rect">
+            <a:avLst/>
+          </a:prstGeom>
+          <a:noFill/>
+        </p:spPr>
+        <p:txBody>
+          <a:bodyPr wrap="square" anchor="t">
+            <a:spAutoFit/>
+          </a:bodyPr>
+          <a:lstStyle/>
+          <a:p>
+            <a:pPr algn="l">
+              <a:lnSpc>
+                <a:spcPct val="105000"/>
+              </a:lnSpc>
+              <a:spcAft>
+                <a:spcPts val="0"/>
+              </a:spcAft>
+            </a:pPr>
+            <a:r>
+              <a:rPr sz="1600" b="1">
+                <a:solidFill>
+                  <a:srgbClr val="1A2332"/>
+                </a:solidFill>
+                <a:latin typeface="Calibri"/>
+              </a:rPr>
+              <a:t>Plan &amp; check</a:t>
+            </a:r>
+          </a:p>
+        </p:txBody>
+      </p:sp>
+      <p:sp>
+        <p:nvSpPr>
+          <p:cNvPr id="14" name="TextBox 13"/>
+          <p:cNvSpPr txBox="1"/>
+          <p:nvPr/>
+        </p:nvSpPr>
+        <p:spPr>
+          <a:xfrm>
+            <a:off x="1508760" y="4453128"/>
+            <a:ext cx="4937760" cy="548640"/>
+          </a:xfrm>
+          <a:prstGeom prst="rect">
+            <a:avLst/>
+          </a:prstGeom>
+          <a:noFill/>
+        </p:spPr>
+        <p:txBody>
+          <a:bodyPr wrap="square" anchor="t">
+            <a:spAutoFit/>
+          </a:bodyPr>
+          <a:lstStyle/>
+          <a:p>
+            <a:pPr algn="l">
+              <a:lnSpc>
+                <a:spcPct val="105000"/>
+              </a:lnSpc>
+              <a:spcAft>
+                <a:spcPts val="0"/>
+              </a:spcAft>
+            </a:pPr>
+            <a:r>
+              <a:rPr sz="1250" b="0">
+                <a:solidFill>
+                  <a:srgbClr val="5C6B73"/>
+                </a:solidFill>
+                <a:latin typeface="Calibri"/>
+              </a:rPr>
+              <a:t>Builds the day, then scans for time clashes and overlaps.</a:t>
+            </a:r>
+          </a:p>
+        </p:txBody>
+      </p:sp>
+      <p:sp>
+        <p:nvSpPr>
+          <p:cNvPr id="15" name="Oval 14"/>
           <p:cNvSpPr/>
           <p:nvPr/>
         </p:nvSpPr>
         <p:spPr>
           <a:xfrm>
-            <a:off x="3310128" y="2514600"/>
-            <a:ext cx="2514600" cy="457200"/>
-          </a:xfrm>
-          <a:prstGeom prst="roundRect">
+            <a:off x="868680" y="5074920"/>
+            <a:ext cx="457200" cy="457200"/>
+          </a:xfrm>
+          <a:prstGeom prst="ellipse">
             <a:avLst/>
           </a:prstGeom>
           <a:solidFill>
@@ -4143,61 +4293,27 @@
           <a:lstStyle/>
           <a:p>
             <a:pPr algn="ctr"/>
-          </a:p>
-        </p:txBody>
-      </p:sp>
-      <p:sp>
-        <p:nvSpPr>
-          <p:cNvPr id="13" name="TextBox 12"/>
+            <a:r>
+              <a:rPr sz="1700" b="1">
+                <a:solidFill>
+                  <a:srgbClr val="FFFFFF"/>
+                </a:solidFill>
+              </a:rPr>
+              <a:t>4</a:t>
+            </a:r>
+          </a:p>
+        </p:txBody>
+      </p:sp>
+      <p:sp>
+        <p:nvSpPr>
+          <p:cNvPr id="16" name="TextBox 15"/>
           <p:cNvSpPr txBox="1"/>
           <p:nvPr/>
         </p:nvSpPr>
         <p:spPr>
           <a:xfrm>
-            <a:off x="3310128" y="2542032"/>
-            <a:ext cx="2514600" cy="402336"/>
-          </a:xfrm>
-          <a:prstGeom prst="rect">
-            <a:avLst/>
-          </a:prstGeom>
-          <a:noFill/>
-        </p:spPr>
-        <p:txBody>
-          <a:bodyPr wrap="square" anchor="t">
-            <a:spAutoFit/>
-          </a:bodyPr>
-          <a:lstStyle/>
-          <a:p>
-            <a:pPr algn="ctr">
-              <a:lnSpc>
-                <a:spcPct val="105000"/>
-              </a:lnSpc>
-              <a:spcAft>
-                <a:spcPts val="0"/>
-              </a:spcAft>
-            </a:pPr>
-            <a:r>
-              <a:rPr sz="1200" b="1">
-                <a:solidFill>
-                  <a:srgbClr val="FFFFFF"/>
-                </a:solidFill>
-                <a:latin typeface="Calibri"/>
-              </a:rPr>
-              <a:t>STEP 2</a:t>
-            </a:r>
-          </a:p>
-        </p:txBody>
-      </p:sp>
-      <p:sp>
-        <p:nvSpPr>
-          <p:cNvPr id="14" name="TextBox 13"/>
-          <p:cNvSpPr txBox="1"/>
-          <p:nvPr/>
-        </p:nvSpPr>
-        <p:spPr>
-          <a:xfrm>
-            <a:off x="3511296" y="3108960"/>
-            <a:ext cx="2148840" cy="640080"/>
+            <a:off x="1508760" y="5020056"/>
+            <a:ext cx="4937760" cy="365760"/>
           </a:xfrm>
           <a:prstGeom prst="rect">
             <a:avLst/>
@@ -4219,27 +4335,27 @@
               </a:spcAft>
             </a:pPr>
             <a:r>
-              <a:rPr sz="1500" b="1">
+              <a:rPr sz="1600" b="1">
                 <a:solidFill>
                   <a:srgbClr val="1A2332"/>
                 </a:solidFill>
                 <a:latin typeface="Calibri"/>
               </a:rPr>
-              <a:t>Prioritize</a:t>
-            </a:r>
-          </a:p>
-        </p:txBody>
-      </p:sp>
-      <p:sp>
-        <p:nvSpPr>
-          <p:cNvPr id="15" name="TextBox 14"/>
+              <a:t>Fix &amp; score</a:t>
+            </a:r>
+          </a:p>
+        </p:txBody>
+      </p:sp>
+      <p:sp>
+        <p:nvSpPr>
+          <p:cNvPr id="17" name="TextBox 16"/>
           <p:cNvSpPr txBox="1"/>
           <p:nvPr/>
         </p:nvSpPr>
         <p:spPr>
           <a:xfrm>
-            <a:off x="3511296" y="3703320"/>
-            <a:ext cx="2148840" cy="1463040"/>
+            <a:off x="1508760" y="5367528"/>
+            <a:ext cx="4937760" cy="548640"/>
           </a:xfrm>
           <a:prstGeom prst="rect">
             <a:avLst/>
@@ -4254,7 +4370,7 @@
           <a:p>
             <a:pPr algn="l">
               <a:lnSpc>
-                <a:spcPct val="110000"/>
+                <a:spcPct val="105000"/>
               </a:lnSpc>
               <a:spcAft>
                 <a:spcPts val="0"/>
@@ -4267,21 +4383,21 @@
                 </a:solidFill>
                 <a:latin typeface="Calibri"/>
               </a:rPr>
-              <a:t>Boosts safety-first tasks: meds › feeding › walks › grooming.</a:t>
-            </a:r>
-          </a:p>
-        </p:txBody>
-      </p:sp>
-      <p:sp>
-        <p:nvSpPr>
-          <p:cNvPr id="16" name="Rounded Rectangle 15"/>
+              <a:t>Resolves conflicts and reports a 0–1 confidence score.</a:t>
+            </a:r>
+          </a:p>
+        </p:txBody>
+      </p:sp>
+      <p:sp>
+        <p:nvSpPr>
+          <p:cNvPr id="18" name="Rounded Rectangle 17"/>
           <p:cNvSpPr/>
           <p:nvPr/>
         </p:nvSpPr>
         <p:spPr>
           <a:xfrm>
-            <a:off x="5980176" y="2514600"/>
-            <a:ext cx="2514600" cy="2743200"/>
+            <a:off x="6720840" y="1783080"/>
+            <a:ext cx="4846320" cy="3827678"/>
           </a:xfrm>
           <a:prstGeom prst="roundRect">
             <a:avLst/>
@@ -4318,100 +4434,14 @@
       </p:sp>
       <p:sp>
         <p:nvSpPr>
-          <p:cNvPr id="17" name="Rounded Rectangle 16"/>
-          <p:cNvSpPr/>
-          <p:nvPr/>
-        </p:nvSpPr>
-        <p:spPr>
-          <a:xfrm>
-            <a:off x="5980176" y="2514600"/>
-            <a:ext cx="2514600" cy="457200"/>
-          </a:xfrm>
-          <a:prstGeom prst="roundRect">
-            <a:avLst/>
-          </a:prstGeom>
-          <a:solidFill>
-            <a:srgbClr val="148F93"/>
-          </a:solidFill>
-          <a:ln>
-            <a:noFill/>
-          </a:ln>
-          <a:effectLst/>
-        </p:spPr>
-        <p:style>
-          <a:lnRef idx="1">
-            <a:schemeClr val="accent1"/>
-          </a:lnRef>
-          <a:fillRef idx="3">
-            <a:schemeClr val="accent1"/>
-          </a:fillRef>
-          <a:effectRef idx="2">
-            <a:schemeClr val="accent1"/>
-          </a:effectRef>
-          <a:fontRef idx="minor">
-            <a:schemeClr val="lt1"/>
-          </a:fontRef>
-        </p:style>
-        <p:txBody>
-          <a:bodyPr rtlCol="0" anchor="ctr"/>
-          <a:lstStyle/>
-          <a:p>
-            <a:pPr algn="ctr"/>
-          </a:p>
-        </p:txBody>
-      </p:sp>
-      <p:sp>
-        <p:nvSpPr>
-          <p:cNvPr id="18" name="TextBox 17"/>
-          <p:cNvSpPr txBox="1"/>
-          <p:nvPr/>
-        </p:nvSpPr>
-        <p:spPr>
-          <a:xfrm>
-            <a:off x="5980176" y="2542032"/>
-            <a:ext cx="2514600" cy="402336"/>
-          </a:xfrm>
-          <a:prstGeom prst="rect">
-            <a:avLst/>
-          </a:prstGeom>
-          <a:noFill/>
-        </p:spPr>
-        <p:txBody>
-          <a:bodyPr wrap="square" anchor="t">
-            <a:spAutoFit/>
-          </a:bodyPr>
-          <a:lstStyle/>
-          <a:p>
-            <a:pPr algn="ctr">
-              <a:lnSpc>
-                <a:spcPct val="105000"/>
-              </a:lnSpc>
-              <a:spcAft>
-                <a:spcPts val="0"/>
-              </a:spcAft>
-            </a:pPr>
-            <a:r>
-              <a:rPr sz="1200" b="1">
-                <a:solidFill>
-                  <a:srgbClr val="FFFFFF"/>
-                </a:solidFill>
-                <a:latin typeface="Calibri"/>
-              </a:rPr>
-              <a:t>STEP 3</a:t>
-            </a:r>
-          </a:p>
-        </p:txBody>
-      </p:sp>
-      <p:sp>
-        <p:nvSpPr>
           <p:cNvPr id="19" name="TextBox 18"/>
           <p:cNvSpPr txBox="1"/>
           <p:nvPr/>
         </p:nvSpPr>
         <p:spPr>
           <a:xfrm>
-            <a:off x="6181344" y="3108960"/>
-            <a:ext cx="2148840" cy="640080"/>
+            <a:off x="6903720" y="1892808"/>
+            <a:ext cx="4480560" cy="320040"/>
           </a:xfrm>
           <a:prstGeom prst="rect">
             <a:avLst/>
@@ -4433,199 +4463,51 @@
               </a:spcAft>
             </a:pPr>
             <a:r>
-              <a:rPr sz="1500" b="1">
-                <a:solidFill>
-                  <a:srgbClr val="1A2332"/>
+              <a:rPr sz="1100" b="1">
+                <a:solidFill>
+                  <a:srgbClr val="148F93"/>
                 </a:solidFill>
                 <a:latin typeface="Calibri"/>
               </a:rPr>
-              <a:t>Plan &amp; check</a:t>
-            </a:r>
-          </a:p>
-        </p:txBody>
-      </p:sp>
-      <p:sp>
-        <p:nvSpPr>
-          <p:cNvPr id="20" name="TextBox 19"/>
-          <p:cNvSpPr txBox="1"/>
+              <a:t>THE LIVE APP</a:t>
+            </a:r>
+          </a:p>
+        </p:txBody>
+      </p:sp>
+      <p:pic>
+        <p:nvPicPr>
+          <p:cNvPr id="20" name="Picture 19" descr="app_screenshot.png"/>
+          <p:cNvPicPr>
+            <a:picLocks noChangeAspect="1"/>
+          </p:cNvPicPr>
           <p:nvPr/>
-        </p:nvSpPr>
-        <p:spPr>
-          <a:xfrm>
-            <a:off x="6181344" y="3703320"/>
-            <a:ext cx="2148840" cy="1463040"/>
+        </p:nvPicPr>
+        <p:blipFill>
+          <a:blip r:embed="rId2"/>
+          <a:stretch>
+            <a:fillRect/>
+          </a:stretch>
+        </p:blipFill>
+        <p:spPr>
+          <a:xfrm>
+            <a:off x="6812280" y="2240280"/>
+            <a:ext cx="4663440" cy="3233318"/>
           </a:xfrm>
           <a:prstGeom prst="rect">
             <a:avLst/>
           </a:prstGeom>
-          <a:noFill/>
-        </p:spPr>
-        <p:txBody>
-          <a:bodyPr wrap="square" anchor="t">
-            <a:spAutoFit/>
-          </a:bodyPr>
-          <a:lstStyle/>
-          <a:p>
-            <a:pPr algn="l">
-              <a:lnSpc>
-                <a:spcPct val="110000"/>
-              </a:lnSpc>
-              <a:spcAft>
-                <a:spcPts val="0"/>
-              </a:spcAft>
-            </a:pPr>
-            <a:r>
-              <a:rPr sz="1250" b="0">
-                <a:solidFill>
-                  <a:srgbClr val="5C6B73"/>
-                </a:solidFill>
-                <a:latin typeface="Calibri"/>
-              </a:rPr>
-              <a:t>Builds the day, then scans for time clashes and overlaps.</a:t>
-            </a:r>
-          </a:p>
-        </p:txBody>
-      </p:sp>
-      <p:sp>
-        <p:nvSpPr>
-          <p:cNvPr id="21" name="Rounded Rectangle 20"/>
-          <p:cNvSpPr/>
-          <p:nvPr/>
-        </p:nvSpPr>
-        <p:spPr>
-          <a:xfrm>
-            <a:off x="8650224" y="2514600"/>
-            <a:ext cx="2514600" cy="2743200"/>
-          </a:xfrm>
-          <a:prstGeom prst="roundRect">
-            <a:avLst/>
-          </a:prstGeom>
-          <a:solidFill>
-            <a:srgbClr val="FFFFFF"/>
-          </a:solidFill>
-          <a:ln>
-            <a:noFill/>
-          </a:ln>
-          <a:effectLst/>
-        </p:spPr>
-        <p:style>
-          <a:lnRef idx="1">
-            <a:schemeClr val="accent1"/>
-          </a:lnRef>
-          <a:fillRef idx="3">
-            <a:schemeClr val="accent1"/>
-          </a:fillRef>
-          <a:effectRef idx="2">
-            <a:schemeClr val="accent1"/>
-          </a:effectRef>
-          <a:fontRef idx="minor">
-            <a:schemeClr val="lt1"/>
-          </a:fontRef>
-        </p:style>
-        <p:txBody>
-          <a:bodyPr rtlCol="0" anchor="ctr"/>
-          <a:lstStyle/>
-          <a:p>
-            <a:pPr algn="ctr"/>
-          </a:p>
-        </p:txBody>
-      </p:sp>
-      <p:sp>
-        <p:nvSpPr>
-          <p:cNvPr id="22" name="Rounded Rectangle 21"/>
-          <p:cNvSpPr/>
-          <p:nvPr/>
-        </p:nvSpPr>
-        <p:spPr>
-          <a:xfrm>
-            <a:off x="8650224" y="2514600"/>
-            <a:ext cx="2514600" cy="457200"/>
-          </a:xfrm>
-          <a:prstGeom prst="roundRect">
-            <a:avLst/>
-          </a:prstGeom>
-          <a:solidFill>
-            <a:srgbClr val="148F93"/>
-          </a:solidFill>
-          <a:ln>
-            <a:noFill/>
-          </a:ln>
-          <a:effectLst/>
-        </p:spPr>
-        <p:style>
-          <a:lnRef idx="1">
-            <a:schemeClr val="accent1"/>
-          </a:lnRef>
-          <a:fillRef idx="3">
-            <a:schemeClr val="accent1"/>
-          </a:fillRef>
-          <a:effectRef idx="2">
-            <a:schemeClr val="accent1"/>
-          </a:effectRef>
-          <a:fontRef idx="minor">
-            <a:schemeClr val="lt1"/>
-          </a:fontRef>
-        </p:style>
-        <p:txBody>
-          <a:bodyPr rtlCol="0" anchor="ctr"/>
-          <a:lstStyle/>
-          <a:p>
-            <a:pPr algn="ctr"/>
-          </a:p>
-        </p:txBody>
-      </p:sp>
-      <p:sp>
-        <p:nvSpPr>
-          <p:cNvPr id="23" name="TextBox 22"/>
+        </p:spPr>
+      </p:pic>
+      <p:sp>
+        <p:nvSpPr>
+          <p:cNvPr id="21" name="TextBox 20"/>
           <p:cNvSpPr txBox="1"/>
           <p:nvPr/>
         </p:nvSpPr>
         <p:spPr>
           <a:xfrm>
-            <a:off x="8650224" y="2542032"/>
-            <a:ext cx="2514600" cy="402336"/>
-          </a:xfrm>
-          <a:prstGeom prst="rect">
-            <a:avLst/>
-          </a:prstGeom>
-          <a:noFill/>
-        </p:spPr>
-        <p:txBody>
-          <a:bodyPr wrap="square" anchor="t">
-            <a:spAutoFit/>
-          </a:bodyPr>
-          <a:lstStyle/>
-          <a:p>
-            <a:pPr algn="ctr">
-              <a:lnSpc>
-                <a:spcPct val="105000"/>
-              </a:lnSpc>
-              <a:spcAft>
-                <a:spcPts val="0"/>
-              </a:spcAft>
-            </a:pPr>
-            <a:r>
-              <a:rPr sz="1200" b="1">
-                <a:solidFill>
-                  <a:srgbClr val="FFFFFF"/>
-                </a:solidFill>
-                <a:latin typeface="Calibri"/>
-              </a:rPr>
-              <a:t>STEP 4</a:t>
-            </a:r>
-          </a:p>
-        </p:txBody>
-      </p:sp>
-      <p:sp>
-        <p:nvSpPr>
-          <p:cNvPr id="24" name="TextBox 23"/>
-          <p:cNvSpPr txBox="1"/>
-          <p:nvPr/>
-        </p:nvSpPr>
-        <p:spPr>
-          <a:xfrm>
-            <a:off x="8851392" y="3108960"/>
-            <a:ext cx="2148840" cy="640080"/>
+            <a:off x="914400" y="5989320"/>
+            <a:ext cx="5669280" cy="548640"/>
           </a:xfrm>
           <a:prstGeom prst="rect">
             <a:avLst/>
@@ -4647,97 +4529,13 @@
               </a:spcAft>
             </a:pPr>
             <a:r>
-              <a:rPr sz="1500" b="1">
-                <a:solidFill>
-                  <a:srgbClr val="1A2332"/>
+              <a:rPr sz="1250" b="0">
+                <a:solidFill>
+                  <a:srgbClr val="2A333B"/>
                 </a:solidFill>
                 <a:latin typeface="Calibri"/>
               </a:rPr>
-              <a:t>Fix &amp; score</a:t>
-            </a:r>
-          </a:p>
-        </p:txBody>
-      </p:sp>
-      <p:sp>
-        <p:nvSpPr>
-          <p:cNvPr id="25" name="TextBox 24"/>
-          <p:cNvSpPr txBox="1"/>
-          <p:nvPr/>
-        </p:nvSpPr>
-        <p:spPr>
-          <a:xfrm>
-            <a:off x="8851392" y="3703320"/>
-            <a:ext cx="2148840" cy="1463040"/>
-          </a:xfrm>
-          <a:prstGeom prst="rect">
-            <a:avLst/>
-          </a:prstGeom>
-          <a:noFill/>
-        </p:spPr>
-        <p:txBody>
-          <a:bodyPr wrap="square" anchor="t">
-            <a:spAutoFit/>
-          </a:bodyPr>
-          <a:lstStyle/>
-          <a:p>
-            <a:pPr algn="l">
-              <a:lnSpc>
-                <a:spcPct val="110000"/>
-              </a:lnSpc>
-              <a:spcAft>
-                <a:spcPts val="0"/>
-              </a:spcAft>
-            </a:pPr>
-            <a:r>
-              <a:rPr sz="1250" b="0">
-                <a:solidFill>
-                  <a:srgbClr val="5C6B73"/>
-                </a:solidFill>
-                <a:latin typeface="Calibri"/>
-              </a:rPr>
-              <a:t>Resolves conflicts and reports a 0–1 confidence score.</a:t>
-            </a:r>
-          </a:p>
-        </p:txBody>
-      </p:sp>
-      <p:sp>
-        <p:nvSpPr>
-          <p:cNvPr id="26" name="TextBox 25"/>
-          <p:cNvSpPr txBox="1"/>
-          <p:nvPr/>
-        </p:nvSpPr>
-        <p:spPr>
-          <a:xfrm>
-            <a:off x="914400" y="5532120"/>
-            <a:ext cx="10332720" cy="548640"/>
-          </a:xfrm>
-          <a:prstGeom prst="rect">
-            <a:avLst/>
-          </a:prstGeom>
-          <a:noFill/>
-        </p:spPr>
-        <p:txBody>
-          <a:bodyPr wrap="square" anchor="t">
-            <a:spAutoFit/>
-          </a:bodyPr>
-          <a:lstStyle/>
-          <a:p>
-            <a:pPr algn="l">
-              <a:lnSpc>
-                <a:spcPct val="105000"/>
-              </a:lnSpc>
-              <a:spcAft>
-                <a:spcPts val="0"/>
-              </a:spcAft>
-            </a:pPr>
-            <a:r>
-              <a:rPr sz="1400" b="0">
-                <a:solidFill>
-                  <a:srgbClr val="2A333B"/>
-                </a:solidFill>
-                <a:latin typeface="Calibri"/>
-              </a:rPr>
-              <a:t>Every step is written to a trace, so you can read exactly why the plan came out that way.</a:t>
+              <a:t>Every step is logged to a trace — you can read why the plan came out this way.</a:t>
             </a:r>
           </a:p>
         </p:txBody>

</xml_diff>